<commit_message>
chore: wire vieschool.com custom domains across the suite
ea.vieschool.com -> this app (English Arena), congcuso.vieschool.com ->
tvc360-congcuso, sochunhiem.vieschool.com -> so-chu-nhiem-so. Apex + www
307-redirect to ea until a suite landing exists. DNS via Cloudflare zone
(CNAME -> cname.vercel-dns.com, DNS-only). Deck updated to English Arena
naming + live domain map.

Generated with [Devin](https://devin.ai)

Co-Authored-By: Devin <158243242+devin-ai-integration[bot]@users.noreply.github.com>
</commit_message>
<xml_diff>
--- a/docs/proposal-vieschool-sales.pptx
+++ b/docs/proposal-vieschool-sales.pptx
@@ -3614,7 +3614,7 @@
                 </a:solidFill>
                 <a:latin typeface="Segoe UI"/>
               </a:rPr>
-              <a:t>VieSchool English</a:t>
+              <a:t>VieSchool EA</a:t>
             </a:r>
           </a:p>
         </p:txBody>
@@ -3656,7 +3656,7 @@
                 </a:solidFill>
                 <a:latin typeface="Segoe UI"/>
               </a:rPr>
-              <a:t>Luyện tiếng Anh G1-5</a:t>
+              <a:t>English Arena - Luyện TA G1-5</a:t>
             </a:r>
           </a:p>
         </p:txBody>
@@ -4046,7 +4046,7 @@
                 </a:solidFill>
                 <a:latin typeface="Segoe UI"/>
               </a:rPr>
-              <a:t>vieschool.vn - vieschool.com</a:t>
+              <a:t>vieschool.com - ea - congcuso - sochunhiem</a:t>
             </a:r>
             <a:r>
               <a:rPr sz="1200" b="0">
@@ -4167,7 +4167,7 @@
                 </a:solidFill>
                 <a:latin typeface="Segoe UI"/>
               </a:rPr>
-              <a:t>Bản đồ hành trình 5 vùng đất - VieSchool English</a:t>
+              <a:t>Bản đồ hành trình 5 vùng đất - English Arena</a:t>
             </a:r>
           </a:p>
         </p:txBody>
@@ -5151,7 +5151,7 @@
                 </a:solidFill>
                 <a:latin typeface="Segoe UI"/>
               </a:rPr>
-              <a:t>Một tên miền vieschool.vn - subdomain cho từng sản phẩm</a:t>
+              <a:t>Một tên miền vieschool.com - subdomain cho từng sản phẩm</a:t>
             </a:r>
           </a:p>
         </p:txBody>
@@ -5376,7 +5376,7 @@
                 </a:solidFill>
                 <a:latin typeface="Segoe UI"/>
               </a:rPr>
-              <a:t>vieschool.vn</a:t>
+              <a:t>vieschool.com</a:t>
             </a:r>
             <a:r>
               <a:rPr sz="1050" b="0">
@@ -5427,7 +5427,7 @@
                 </a:solidFill>
                 <a:latin typeface="Segoe UI"/>
               </a:rPr>
-              <a:t>tienganh.vieschool.vn</a:t>
+              <a:t>ea.vieschool.com</a:t>
             </a:r>
             <a:r>
               <a:rPr sz="1050" b="0">
@@ -5436,7 +5436,7 @@
                 </a:solidFill>
                 <a:latin typeface="Segoe UI"/>
               </a:rPr>
-              <a:t>   VieSchool English - app luyện tập</a:t>
+              <a:t>   English Arena - app luyện tập</a:t>
             </a:r>
           </a:p>
         </p:txBody>
@@ -5478,7 +5478,7 @@
                 </a:solidFill>
                 <a:latin typeface="Segoe UI"/>
               </a:rPr>
-              <a:t>congcuso.vieschool.vn</a:t>
+              <a:t>congcuso.vieschool.com</a:t>
             </a:r>
             <a:r>
               <a:rPr sz="1050" b="0">
@@ -5529,7 +5529,7 @@
                 </a:solidFill>
                 <a:latin typeface="Segoe UI"/>
               </a:rPr>
-              <a:t>sochunhiem.vieschool.vn</a:t>
+              <a:t>sochunhiem.vieschool.com</a:t>
             </a:r>
             <a:r>
               <a:rPr sz="1050" b="0">
@@ -5670,7 +5670,7 @@
                 </a:solidFill>
                 <a:latin typeface="Segoe UI"/>
               </a:rPr>
-              <a:t>vieschool.vn tại iNET - ~450.000đ/năm</a:t>
+              <a:t>vieschool.com tại Cloudflare - ~260.000đ/năm - ĐÃ MUA</a:t>
             </a:r>
             <a:r>
               <a:rPr sz="1050" b="0">
@@ -5698,7 +5698,7 @@
                 </a:solidFill>
                 <a:latin typeface="Segoe UI"/>
               </a:rPr>
-              <a:t>vieschool.com tại Cloudflare - ~260.000đ/năm</a:t>
+              <a:t>vieschool.vn tại iNET - ~450.000đ/năm - mua thêm nếu cần</a:t>
             </a:r>
             <a:r>
               <a:rPr sz="1050" b="0">
@@ -5707,7 +5707,7 @@
                 </a:solidFill>
                 <a:latin typeface="Segoe UI"/>
               </a:rPr>
-              <a:t>  (giá gốc, không tăng khi gia hạn; DNS mạnh, gắn Vercel 2 click)</a:t>
+              <a:t>  (giữ thương hiệu .vn cho đợt bán trường; trỏ cùng site)</a:t>
             </a:r>
           </a:p>
           <a:p>
@@ -5726,7 +5726,7 @@
                 </a:solidFill>
                 <a:latin typeface="Segoe UI"/>
               </a:rPr>
-              <a:t>Tổng ~710.000đ/năm cho cả hệ sinh thái</a:t>
+              <a:t>DNS đã trỏ Vercel - subdomain miễn phí không giới hạn</a:t>
             </a:r>
           </a:p>
         </p:txBody>
@@ -5814,7 +5814,7 @@
                 </a:solidFill>
                 <a:latin typeface="Segoe UI"/>
               </a:rPr>
-              <a:t>Lộ trình 30-60-90 ngày:  (1) Mua domain + gắn Vercel, chạy pilot 1-2 lớp miễn phí để lấy case study - (2) Chốt gói trường, đẩy VieSchool Tools cho GV trường đó - (3) Hoàn thiện Sổ CN, bán nguyên suite theo năm học mới.</a:t>
+              <a:t>Lộ trình 30-60-90 ngày:  (1) Chạy pilot 1-2 lớp miễn phí trên ea.vieschool.com để lấy case study - (2) Chốt gói trường, đẩy VieSchool Tools cho GV trường đó - (3) Hoàn thiện Sổ CN, bán nguyên suite theo năm học mới.</a:t>
             </a:r>
           </a:p>
         </p:txBody>
@@ -7242,7 +7242,7 @@
                 </a:solidFill>
                 <a:latin typeface="Segoe UI"/>
               </a:rPr>
-              <a:t>VieSchool English</a:t>
+              <a:t>English Arena</a:t>
             </a:r>
           </a:p>
         </p:txBody>
@@ -8216,7 +8216,7 @@
                 </a:solidFill>
                 <a:latin typeface="Segoe UI"/>
               </a:rPr>
-              <a:t>VieSchool English - app luyện tập trẻ tự mở mỗi ngày</a:t>
+              <a:t>English Arena - app luyện tập trẻ tự mở mỗi ngày</a:t>
             </a:r>
           </a:p>
         </p:txBody>
@@ -10580,7 +10580,7 @@
                 </a:solidFill>
                 <a:latin typeface="Segoe UI"/>
               </a:rPr>
-              <a:t>VieSchool English so với các lựa chọn hiện có</a:t>
+              <a:t>English Arena so với các lựa chọn hiện có</a:t>
             </a:r>
           </a:p>
         </p:txBody>
@@ -10849,7 +10849,7 @@
                 </a:solidFill>
                 <a:latin typeface="Segoe UI"/>
               </a:rPr>
-              <a:t>VieSchool</a:t>
+              <a:t>English Arena</a:t>
             </a:r>
           </a:p>
         </p:txBody>

</xml_diff>

<commit_message>
docs: proposal + deck regen (1100+), CR-15 closed in backlog
Generated with [Devin](https://devin.ai)

Co-Authored-By: Devin <158243242+devin-ai-integration[bot]@users.noreply.github.com>
</commit_message>
<xml_diff>
--- a/docs/proposal-vieschool-sales.pptx
+++ b/docs/proposal-vieschool-sales.pptx
@@ -3300,8 +3300,8 @@
         </p:blipFill>
         <p:spPr>
           <a:xfrm>
-            <a:off x="3579223" y="4206240"/>
-            <a:ext cx="5094514" cy="2377440"/>
+            <a:off x="4224528" y="4206240"/>
+            <a:ext cx="3803904" cy="2377440"/>
           </a:xfrm>
           <a:prstGeom prst="rect">
             <a:avLst/>
@@ -3456,8 +3456,8 @@
         </p:blipFill>
         <p:spPr>
           <a:xfrm>
-            <a:off x="548640" y="2490216"/>
-            <a:ext cx="6766560" cy="3157728"/>
+            <a:off x="548640" y="1954530"/>
+            <a:ext cx="6766560" cy="4229100"/>
           </a:xfrm>
           <a:prstGeom prst="rect">
             <a:avLst/>
@@ -3659,8 +3659,8 @@
         </p:blipFill>
         <p:spPr>
           <a:xfrm>
-            <a:off x="548640" y="2490216"/>
-            <a:ext cx="6766560" cy="3157728"/>
+            <a:off x="548640" y="1954530"/>
+            <a:ext cx="6766560" cy="4229100"/>
           </a:xfrm>
           <a:prstGeom prst="rect">
             <a:avLst/>
@@ -3862,8 +3862,8 @@
         </p:blipFill>
         <p:spPr>
           <a:xfrm>
-            <a:off x="548640" y="2490216"/>
-            <a:ext cx="6766560" cy="3157728"/>
+            <a:off x="548640" y="1954530"/>
+            <a:ext cx="6766560" cy="4229100"/>
           </a:xfrm>
           <a:prstGeom prst="rect">
             <a:avLst/>
@@ -5922,7 +5922,7 @@
                 </a:solidFill>
                 <a:latin typeface="Avenir Next"/>
               </a:rPr>
-              <a:t>524+ từ vựng bám SGK</a:t>
+              <a:t>1100+ từ vựng bám SGK</a:t>
             </a:r>
           </a:p>
         </p:txBody>
@@ -8677,8 +8677,8 @@
         </p:blipFill>
         <p:spPr>
           <a:xfrm>
-            <a:off x="548640" y="2490216"/>
-            <a:ext cx="6766560" cy="3157728"/>
+            <a:off x="548640" y="1954530"/>
+            <a:ext cx="6766560" cy="4229100"/>
           </a:xfrm>
           <a:prstGeom prst="rect">
             <a:avLst/>
@@ -8880,8 +8880,8 @@
         </p:blipFill>
         <p:spPr>
           <a:xfrm>
-            <a:off x="548640" y="2490216"/>
-            <a:ext cx="6766560" cy="3157728"/>
+            <a:off x="548640" y="1954530"/>
+            <a:ext cx="6766560" cy="4229100"/>
           </a:xfrm>
           <a:prstGeom prst="rect">
             <a:avLst/>

</xml_diff>

<commit_message>
docs: sales deck + landing claim updated for exam mode (200q/30min)
</commit_message>
<xml_diff>
--- a/docs/proposal-vieschool-sales.pptx
+++ b/docs/proposal-vieschool-sales.pptx
@@ -5319,6 +5319,30 @@
                 <a:latin typeface="Avenir Next"/>
               </a:rPr>
               <a:t>4 vòng chơi, phát âm chấm điểm.</a:t>
+            </a:r>
+          </a:p>
+          <a:p>
+            <a:pPr algn="l"/>
+            <a:r>
+              <a:rPr sz="1200" b="0">
+                <a:solidFill>
+                  <a:srgbClr val="F4F6FB"/>
+                </a:solidFill>
+                <a:latin typeface="Avenir Next"/>
+              </a:rPr>
+              <a:t>Luyện đề + Thi thử 200 câu/30 phút,</a:t>
+            </a:r>
+          </a:p>
+          <a:p>
+            <a:pPr algn="l"/>
+            <a:r>
+              <a:rPr sz="1200" b="0">
+                <a:solidFill>
+                  <a:srgbClr val="F4F6FB"/>
+                </a:solidFill>
+                <a:latin typeface="Avenir Next"/>
+              </a:rPr>
+              <a:t>đề bám format IOE theo khối.</a:t>
             </a:r>
           </a:p>
           <a:p>

</xml_diff>